<commit_message>
Add application match score sync endpoint
</commit_message>
<xml_diff>
--- a/for review/Jobify_AI_Backend_Doctor_Presentation.pptx
+++ b/for review/Jobify_AI_Backend_Doctor_Presentation.pptx
@@ -23,6 +23,7 @@
     <p:sldId id="271" r:id="rId22"/>
     <p:sldId id="272" r:id="rId23"/>
     <p:sldId id="273" r:id="rId24"/>
+    <p:sldId id="274" r:id="rId25"/>
   </p:sldIdLst>
   <p:sldSz cx="12191999" cy="6858000" type="screen4x3"/>
   <p:notesSz cx="6858000" cy="9144000"/>
@@ -8398,6 +8399,602 @@
 </p:sld>
 </file>
 
+<file path=ppt/slides/slide19.xml><?xml version="1.0" encoding="utf-8"?>
+<p:sld xmlns:a="http://schemas.openxmlformats.org/drawingml/2006/main" xmlns:p="http://schemas.openxmlformats.org/presentationml/2006/main" xmlns:r="http://schemas.openxmlformats.org/officeDocument/2006/relationships">
+  <p:cSld>
+    <p:bg>
+      <p:bgPr>
+        <a:solidFill>
+          <a:srgbClr val="F7F9FC"/>
+        </a:solidFill>
+        <a:effectLst/>
+      </p:bgPr>
+    </p:bg>
+    <p:spTree>
+      <p:nvGrpSpPr>
+        <p:cNvPr id="1" name=""/>
+        <p:cNvGrpSpPr/>
+        <p:nvPr/>
+      </p:nvGrpSpPr>
+      <p:grpSpPr/>
+      <p:sp>
+        <p:nvSpPr>
+          <p:cNvPr id="2" name="TextBox 1"/>
+          <p:cNvSpPr txBox="1"/>
+          <p:nvPr/>
+        </p:nvSpPr>
+        <p:spPr>
+          <a:xfrm>
+            <a:off x="548640" y="320040"/>
+            <a:ext cx="11064240" cy="685800"/>
+          </a:xfrm>
+          <a:prstGeom prst="rect">
+            <a:avLst/>
+          </a:prstGeom>
+          <a:noFill/>
+        </p:spPr>
+        <p:txBody>
+          <a:bodyPr wrap="none">
+            <a:spAutoFit/>
+          </a:bodyPr>
+          <a:lstStyle/>
+          <a:p>
+            <a:pPr>
+              <a:defRPr b="1" sz="3400">
+                <a:solidFill>
+                  <a:srgbClr val="132543"/>
+                </a:solidFill>
+              </a:defRPr>
+            </a:pPr>
+            <a:r>
+              <a:t>Featured Jobs Priority</a:t>
+            </a:r>
+          </a:p>
+        </p:txBody>
+      </p:sp>
+      <p:sp>
+        <p:nvSpPr>
+          <p:cNvPr id="3" name="TextBox 2"/>
+          <p:cNvSpPr txBox="1"/>
+          <p:nvPr/>
+        </p:nvSpPr>
+        <p:spPr>
+          <a:xfrm>
+            <a:off x="594360" y="987552"/>
+            <a:ext cx="10698480" cy="411480"/>
+          </a:xfrm>
+          <a:prstGeom prst="rect">
+            <a:avLst/>
+          </a:prstGeom>
+          <a:noFill/>
+        </p:spPr>
+        <p:txBody>
+          <a:bodyPr wrap="none">
+            <a:spAutoFit/>
+          </a:bodyPr>
+          <a:lstStyle/>
+          <a:p>
+            <a:pPr>
+              <a:defRPr sz="1500">
+                <a:solidFill>
+                  <a:srgbClr val="505B6E"/>
+                </a:solidFill>
+              </a:defRPr>
+            </a:pPr>
+            <a:r>
+              <a:t>Featured jobs from the deployed database are promoted before normal Kaggle jobs.</a:t>
+            </a:r>
+          </a:p>
+        </p:txBody>
+      </p:sp>
+      <p:sp>
+        <p:nvSpPr>
+          <p:cNvPr id="4" name="Rectangle 3"/>
+          <p:cNvSpPr/>
+          <p:nvPr/>
+        </p:nvSpPr>
+        <p:spPr>
+          <a:xfrm>
+            <a:off x="685800" y="1645920"/>
+            <a:ext cx="3520440" cy="3474720"/>
+          </a:xfrm>
+          <a:prstGeom prst="rect">
+            <a:avLst/>
+          </a:prstGeom>
+          <a:solidFill>
+            <a:srgbClr val="FFFFFF"/>
+          </a:solidFill>
+          <a:ln w="12700">
+            <a:solidFill>
+              <a:srgbClr val="E0E5EE"/>
+            </a:solidFill>
+          </a:ln>
+        </p:spPr>
+        <p:style>
+          <a:lnRef idx="1">
+            <a:schemeClr val="accent1"/>
+          </a:lnRef>
+          <a:fillRef idx="3">
+            <a:schemeClr val="accent1"/>
+          </a:fillRef>
+          <a:effectRef idx="2">
+            <a:schemeClr val="accent1"/>
+          </a:effectRef>
+          <a:fontRef idx="minor">
+            <a:schemeClr val="lt1"/>
+          </a:fontRef>
+        </p:style>
+        <p:txBody>
+          <a:bodyPr rtlCol="0" anchor="ctr"/>
+          <a:lstStyle/>
+          <a:p>
+            <a:pPr algn="ctr"/>
+          </a:p>
+        </p:txBody>
+      </p:sp>
+      <p:sp>
+        <p:nvSpPr>
+          <p:cNvPr id="5" name="Rectangle 4"/>
+          <p:cNvSpPr/>
+          <p:nvPr/>
+        </p:nvSpPr>
+        <p:spPr>
+          <a:xfrm>
+            <a:off x="685800" y="1645920"/>
+            <a:ext cx="73152" cy="3474720"/>
+          </a:xfrm>
+          <a:prstGeom prst="rect">
+            <a:avLst/>
+          </a:prstGeom>
+          <a:solidFill>
+            <a:srgbClr val="2563EB"/>
+          </a:solidFill>
+          <a:ln>
+            <a:solidFill>
+              <a:srgbClr val="2563EB"/>
+            </a:solidFill>
+          </a:ln>
+        </p:spPr>
+        <p:style>
+          <a:lnRef idx="1">
+            <a:schemeClr val="accent1"/>
+          </a:lnRef>
+          <a:fillRef idx="3">
+            <a:schemeClr val="accent1"/>
+          </a:fillRef>
+          <a:effectRef idx="2">
+            <a:schemeClr val="accent1"/>
+          </a:effectRef>
+          <a:fontRef idx="minor">
+            <a:schemeClr val="lt1"/>
+          </a:fontRef>
+        </p:style>
+        <p:txBody>
+          <a:bodyPr rtlCol="0" anchor="ctr"/>
+          <a:lstStyle/>
+          <a:p>
+            <a:pPr algn="ctr"/>
+          </a:p>
+        </p:txBody>
+      </p:sp>
+      <p:sp>
+        <p:nvSpPr>
+          <p:cNvPr id="6" name="TextBox 5"/>
+          <p:cNvSpPr txBox="1"/>
+          <p:nvPr/>
+        </p:nvSpPr>
+        <p:spPr>
+          <a:xfrm>
+            <a:off x="941832" y="1874520"/>
+            <a:ext cx="3108960" cy="3108960"/>
+          </a:xfrm>
+          <a:prstGeom prst="rect">
+            <a:avLst/>
+          </a:prstGeom>
+          <a:noFill/>
+        </p:spPr>
+        <p:txBody>
+          <a:bodyPr wrap="none">
+            <a:spAutoFit/>
+          </a:bodyPr>
+          <a:lstStyle/>
+          <a:p>
+            <a:pPr>
+              <a:defRPr b="1" sz="2000">
+                <a:solidFill>
+                  <a:srgbClr val="132543"/>
+                </a:solidFill>
+              </a:defRPr>
+            </a:pPr>
+            <a:r>
+              <a:t>1. Source</a:t>
+            </a:r>
+          </a:p>
+          <a:p>
+            <a:pPr>
+              <a:spcBef>
+                <a:spcPts val="1000"/>
+              </a:spcBef>
+              <a:defRPr sz="1300">
+                <a:solidFill>
+                  <a:srgbClr val="374151"/>
+                </a:solidFill>
+              </a:defRPr>
+            </a:pPr>
+            <a:r>
+              <a:t>JobPostings.IsFeatured is stored in SQL Server.</a:t>
+            </a:r>
+          </a:p>
+          <a:p>
+            <a:pPr>
+              <a:spcBef>
+                <a:spcPts val="1000"/>
+              </a:spcBef>
+              <a:defRPr sz="1300">
+                <a:solidFill>
+                  <a:srgbClr val="374151"/>
+                </a:solidFill>
+              </a:defRPr>
+            </a:pPr>
+            <a:r>
+              <a:t>Kaggle jobs have no flag, so they remain false.</a:t>
+            </a:r>
+          </a:p>
+        </p:txBody>
+      </p:sp>
+      <p:sp>
+        <p:nvSpPr>
+          <p:cNvPr id="7" name="Rectangle 6"/>
+          <p:cNvSpPr/>
+          <p:nvPr/>
+        </p:nvSpPr>
+        <p:spPr>
+          <a:xfrm>
+            <a:off x="4526280" y="1645920"/>
+            <a:ext cx="3520440" cy="3474720"/>
+          </a:xfrm>
+          <a:prstGeom prst="rect">
+            <a:avLst/>
+          </a:prstGeom>
+          <a:solidFill>
+            <a:srgbClr val="FFFFFF"/>
+          </a:solidFill>
+          <a:ln w="12700">
+            <a:solidFill>
+              <a:srgbClr val="E0E5EE"/>
+            </a:solidFill>
+          </a:ln>
+        </p:spPr>
+        <p:style>
+          <a:lnRef idx="1">
+            <a:schemeClr val="accent1"/>
+          </a:lnRef>
+          <a:fillRef idx="3">
+            <a:schemeClr val="accent1"/>
+          </a:fillRef>
+          <a:effectRef idx="2">
+            <a:schemeClr val="accent1"/>
+          </a:effectRef>
+          <a:fontRef idx="minor">
+            <a:schemeClr val="lt1"/>
+          </a:fontRef>
+        </p:style>
+        <p:txBody>
+          <a:bodyPr rtlCol="0" anchor="ctr"/>
+          <a:lstStyle/>
+          <a:p>
+            <a:pPr algn="ctr"/>
+          </a:p>
+        </p:txBody>
+      </p:sp>
+      <p:sp>
+        <p:nvSpPr>
+          <p:cNvPr id="8" name="Rectangle 7"/>
+          <p:cNvSpPr/>
+          <p:nvPr/>
+        </p:nvSpPr>
+        <p:spPr>
+          <a:xfrm>
+            <a:off x="4526280" y="1645920"/>
+            <a:ext cx="73152" cy="3474720"/>
+          </a:xfrm>
+          <a:prstGeom prst="rect">
+            <a:avLst/>
+          </a:prstGeom>
+          <a:solidFill>
+            <a:srgbClr val="F59E0B"/>
+          </a:solidFill>
+          <a:ln>
+            <a:solidFill>
+              <a:srgbClr val="F59E0B"/>
+            </a:solidFill>
+          </a:ln>
+        </p:spPr>
+        <p:style>
+          <a:lnRef idx="1">
+            <a:schemeClr val="accent1"/>
+          </a:lnRef>
+          <a:fillRef idx="3">
+            <a:schemeClr val="accent1"/>
+          </a:fillRef>
+          <a:effectRef idx="2">
+            <a:schemeClr val="accent1"/>
+          </a:effectRef>
+          <a:fontRef idx="minor">
+            <a:schemeClr val="lt1"/>
+          </a:fontRef>
+        </p:style>
+        <p:txBody>
+          <a:bodyPr rtlCol="0" anchor="ctr"/>
+          <a:lstStyle/>
+          <a:p>
+            <a:pPr algn="ctr"/>
+          </a:p>
+        </p:txBody>
+      </p:sp>
+      <p:sp>
+        <p:nvSpPr>
+          <p:cNvPr id="9" name="TextBox 8"/>
+          <p:cNvSpPr txBox="1"/>
+          <p:nvPr/>
+        </p:nvSpPr>
+        <p:spPr>
+          <a:xfrm>
+            <a:off x="4782312" y="1874520"/>
+            <a:ext cx="3108960" cy="3108960"/>
+          </a:xfrm>
+          <a:prstGeom prst="rect">
+            <a:avLst/>
+          </a:prstGeom>
+          <a:noFill/>
+        </p:spPr>
+        <p:txBody>
+          <a:bodyPr wrap="none">
+            <a:spAutoFit/>
+          </a:bodyPr>
+          <a:lstStyle/>
+          <a:p>
+            <a:pPr>
+              <a:defRPr b="1" sz="2000">
+                <a:solidFill>
+                  <a:srgbClr val="132543"/>
+                </a:solidFill>
+              </a:defRPr>
+            </a:pPr>
+            <a:r>
+              <a:t>2. Sync</a:t>
+            </a:r>
+          </a:p>
+          <a:p>
+            <a:pPr>
+              <a:spcBef>
+                <a:spcPts val="1000"/>
+              </a:spcBef>
+              <a:defRPr sz="1300">
+                <a:solidFill>
+                  <a:srgbClr val="374151"/>
+                </a:solidFill>
+              </a:defRPr>
+            </a:pPr>
+            <a:r>
+              <a:t>POST /admin/sync-job-embedding reads IsFeatured.</a:t>
+            </a:r>
+          </a:p>
+          <a:p>
+            <a:pPr>
+              <a:spcBef>
+                <a:spcPts val="1000"/>
+              </a:spcBef>
+              <a:defRPr sz="1300">
+                <a:solidFill>
+                  <a:srgbClr val="374151"/>
+                </a:solidFill>
+              </a:defRPr>
+            </a:pPr>
+            <a:r>
+              <a:t>The local jobs.db stores it as is_featured.</a:t>
+            </a:r>
+          </a:p>
+        </p:txBody>
+      </p:sp>
+      <p:sp>
+        <p:nvSpPr>
+          <p:cNvPr id="10" name="Rectangle 9"/>
+          <p:cNvSpPr/>
+          <p:nvPr/>
+        </p:nvSpPr>
+        <p:spPr>
+          <a:xfrm>
+            <a:off x="8366760" y="1645920"/>
+            <a:ext cx="3520440" cy="3474720"/>
+          </a:xfrm>
+          <a:prstGeom prst="rect">
+            <a:avLst/>
+          </a:prstGeom>
+          <a:solidFill>
+            <a:srgbClr val="FFFFFF"/>
+          </a:solidFill>
+          <a:ln w="12700">
+            <a:solidFill>
+              <a:srgbClr val="E0E5EE"/>
+            </a:solidFill>
+          </a:ln>
+        </p:spPr>
+        <p:style>
+          <a:lnRef idx="1">
+            <a:schemeClr val="accent1"/>
+          </a:lnRef>
+          <a:fillRef idx="3">
+            <a:schemeClr val="accent1"/>
+          </a:fillRef>
+          <a:effectRef idx="2">
+            <a:schemeClr val="accent1"/>
+          </a:effectRef>
+          <a:fontRef idx="minor">
+            <a:schemeClr val="lt1"/>
+          </a:fontRef>
+        </p:style>
+        <p:txBody>
+          <a:bodyPr rtlCol="0" anchor="ctr"/>
+          <a:lstStyle/>
+          <a:p>
+            <a:pPr algn="ctr"/>
+          </a:p>
+        </p:txBody>
+      </p:sp>
+      <p:sp>
+        <p:nvSpPr>
+          <p:cNvPr id="11" name="Rectangle 10"/>
+          <p:cNvSpPr/>
+          <p:nvPr/>
+        </p:nvSpPr>
+        <p:spPr>
+          <a:xfrm>
+            <a:off x="8366760" y="1645920"/>
+            <a:ext cx="73152" cy="3474720"/>
+          </a:xfrm>
+          <a:prstGeom prst="rect">
+            <a:avLst/>
+          </a:prstGeom>
+          <a:solidFill>
+            <a:srgbClr val="14B8A6"/>
+          </a:solidFill>
+          <a:ln>
+            <a:solidFill>
+              <a:srgbClr val="14B8A6"/>
+            </a:solidFill>
+          </a:ln>
+        </p:spPr>
+        <p:style>
+          <a:lnRef idx="1">
+            <a:schemeClr val="accent1"/>
+          </a:lnRef>
+          <a:fillRef idx="3">
+            <a:schemeClr val="accent1"/>
+          </a:fillRef>
+          <a:effectRef idx="2">
+            <a:schemeClr val="accent1"/>
+          </a:effectRef>
+          <a:fontRef idx="minor">
+            <a:schemeClr val="lt1"/>
+          </a:fontRef>
+        </p:style>
+        <p:txBody>
+          <a:bodyPr rtlCol="0" anchor="ctr"/>
+          <a:lstStyle/>
+          <a:p>
+            <a:pPr algn="ctr"/>
+          </a:p>
+        </p:txBody>
+      </p:sp>
+      <p:sp>
+        <p:nvSpPr>
+          <p:cNvPr id="12" name="TextBox 11"/>
+          <p:cNvSpPr txBox="1"/>
+          <p:nvPr/>
+        </p:nvSpPr>
+        <p:spPr>
+          <a:xfrm>
+            <a:off x="8622792" y="1874520"/>
+            <a:ext cx="3108960" cy="3108960"/>
+          </a:xfrm>
+          <a:prstGeom prst="rect">
+            <a:avLst/>
+          </a:prstGeom>
+          <a:noFill/>
+        </p:spPr>
+        <p:txBody>
+          <a:bodyPr wrap="none">
+            <a:spAutoFit/>
+          </a:bodyPr>
+          <a:lstStyle/>
+          <a:p>
+            <a:pPr>
+              <a:defRPr b="1" sz="2000">
+                <a:solidFill>
+                  <a:srgbClr val="132543"/>
+                </a:solidFill>
+              </a:defRPr>
+            </a:pPr>
+            <a:r>
+              <a:t>3. Results</a:t>
+            </a:r>
+          </a:p>
+          <a:p>
+            <a:pPr>
+              <a:spcBef>
+                <a:spcPts val="1000"/>
+              </a:spcBef>
+              <a:defRPr sz="1300">
+                <a:solidFill>
+                  <a:srgbClr val="374151"/>
+                </a:solidFill>
+              </a:defRPr>
+            </a:pPr>
+            <a:r>
+              <a:t>Search and recommendations sort featured first.</a:t>
+            </a:r>
+          </a:p>
+          <a:p>
+            <a:pPr>
+              <a:spcBef>
+                <a:spcPts val="1000"/>
+              </a:spcBef>
+              <a:defRPr sz="1300">
+                <a:solidFill>
+                  <a:srgbClr val="374151"/>
+                </a:solidFill>
+              </a:defRPr>
+            </a:pPr>
+            <a:r>
+              <a:t>Responses expose isFeatured for UI badges.</a:t>
+            </a:r>
+          </a:p>
+        </p:txBody>
+      </p:sp>
+      <p:sp>
+        <p:nvSpPr>
+          <p:cNvPr id="13" name="TextBox 12"/>
+          <p:cNvSpPr txBox="1"/>
+          <p:nvPr/>
+        </p:nvSpPr>
+        <p:spPr>
+          <a:xfrm>
+            <a:off x="685800" y="5532120"/>
+            <a:ext cx="10972800" cy="502920"/>
+          </a:xfrm>
+          <a:prstGeom prst="rect">
+            <a:avLst/>
+          </a:prstGeom>
+          <a:noFill/>
+        </p:spPr>
+        <p:txBody>
+          <a:bodyPr wrap="none">
+            <a:spAutoFit/>
+          </a:bodyPr>
+          <a:lstStyle/>
+          <a:p>
+            <a:pPr algn="ctr">
+              <a:defRPr sz="1400">
+                <a:solidFill>
+                  <a:srgbClr val="4B5563"/>
+                </a:solidFill>
+              </a:defRPr>
+            </a:pPr>
+            <a:r>
+              <a:t>Backend responsibility: ranking is handled before data reaches the frontend. Frontend only renders the returned order.</a:t>
+            </a:r>
+          </a:p>
+        </p:txBody>
+      </p:sp>
+    </p:spTree>
+  </p:cSld>
+  <p:clrMapOvr>
+    <a:masterClrMapping/>
+  </p:clrMapOvr>
+</p:sld>
+</file>
+
 <file path=ppt/slides/slide2.xml><?xml version="1.0" encoding="utf-8"?>
 <p:sld xmlns:a="http://schemas.openxmlformats.org/drawingml/2006/main" xmlns:p="http://schemas.openxmlformats.org/presentationml/2006/main" xmlns:r="http://schemas.openxmlformats.org/officeDocument/2006/relationships">
   <p:cSld>

</xml_diff>

<commit_message>
Update docs for connected frontend repo
</commit_message>
<xml_diff>
--- a/for review/Jobify_AI_Backend_Doctor_Presentation.pptx
+++ b/for review/Jobify_AI_Backend_Doctor_Presentation.pptx
@@ -24,6 +24,7 @@
     <p:sldId id="272" r:id="rId23"/>
     <p:sldId id="273" r:id="rId24"/>
     <p:sldId id="274" r:id="rId25"/>
+    <p:sldId id="275" r:id="rId26"/>
   </p:sldIdLst>
   <p:sldSz cx="12191999" cy="6858000" type="screen4x3"/>
   <p:notesSz cx="6858000" cy="9144000"/>
@@ -9801,6 +9802,288 @@
 </p:sld>
 </file>
 
+<file path=ppt/slides/slide20.xml><?xml version="1.0" encoding="utf-8"?>
+<p:sld xmlns:a="http://schemas.openxmlformats.org/drawingml/2006/main" xmlns:p="http://schemas.openxmlformats.org/presentationml/2006/main" xmlns:r="http://schemas.openxmlformats.org/officeDocument/2006/relationships">
+  <p:cSld>
+    <p:bg>
+      <p:bgPr>
+        <a:solidFill>
+          <a:srgbClr val="F8FAFC"/>
+        </a:solidFill>
+        <a:effectLst/>
+      </p:bgPr>
+    </p:bg>
+    <p:spTree>
+      <p:nvGrpSpPr>
+        <p:cNvPr id="1" name=""/>
+        <p:cNvGrpSpPr/>
+        <p:nvPr/>
+      </p:nvGrpSpPr>
+      <p:grpSpPr/>
+      <p:sp>
+        <p:nvSpPr>
+          <p:cNvPr id="2" name="TextBox 1"/>
+          <p:cNvSpPr txBox="1"/>
+          <p:nvPr/>
+        </p:nvSpPr>
+        <p:spPr>
+          <a:xfrm>
+            <a:off x="411480" y="320040"/>
+            <a:ext cx="11338560" cy="502920"/>
+          </a:xfrm>
+          <a:prstGeom prst="rect">
+            <a:avLst/>
+          </a:prstGeom>
+          <a:noFill/>
+        </p:spPr>
+        <p:txBody>
+          <a:bodyPr wrap="none">
+            <a:spAutoFit/>
+          </a:bodyPr>
+          <a:lstStyle/>
+          <a:p>
+            <a:r>
+              <a:rPr sz="2800" b="1">
+                <a:solidFill>
+                  <a:srgbClr val="14253F"/>
+                </a:solidFill>
+              </a:rPr>
+              <a:t>Latest Frontend Integration</a:t>
+            </a:r>
+          </a:p>
+        </p:txBody>
+      </p:sp>
+      <p:sp>
+        <p:nvSpPr>
+          <p:cNvPr id="3" name="TextBox 2"/>
+          <p:cNvSpPr txBox="1"/>
+          <p:nvPr/>
+        </p:nvSpPr>
+        <p:spPr>
+          <a:xfrm>
+            <a:off x="594360" y="1097280"/>
+            <a:ext cx="5486400" cy="4297680"/>
+          </a:xfrm>
+          <a:prstGeom prst="rect">
+            <a:avLst/>
+          </a:prstGeom>
+          <a:noFill/>
+        </p:spPr>
+        <p:txBody>
+          <a:bodyPr wrap="square">
+            <a:spAutoFit/>
+          </a:bodyPr>
+          <a:lstStyle/>
+          <a:p>
+            <a:pPr>
+              <a:defRPr sz="1700">
+                <a:solidFill>
+                  <a:srgbClr val="0F172A"/>
+                </a:solidFill>
+              </a:defRPr>
+            </a:pPr>
+            <a:r>
+              <a:t>Fresh frontend cloned from ibrahimsaleh8/Graduation_Project.</a:t>
+            </a:r>
+          </a:p>
+          <a:p>
+            <a:pPr>
+              <a:defRPr sz="1700">
+                <a:solidFill>
+                  <a:srgbClr val="0F172A"/>
+                </a:solidFill>
+              </a:defRPr>
+            </a:pPr>
+            <a:r>
+              <a:t>Next.js proxy routes were added for applicant and company AI flows.</a:t>
+            </a:r>
+          </a:p>
+          <a:p>
+            <a:pPr>
+              <a:defRPr sz="1700">
+                <a:solidFill>
+                  <a:srgbClr val="0F172A"/>
+                </a:solidFill>
+              </a:defRPr>
+            </a:pPr>
+            <a:r>
+              <a:t>Applicant chat calls POST /api/ai/chat.</a:t>
+            </a:r>
+          </a:p>
+          <a:p>
+            <a:pPr>
+              <a:defRPr sz="1700">
+                <a:solidFill>
+                  <a:srgbClr val="0F172A"/>
+                </a:solidFill>
+              </a:defRPr>
+            </a:pPr>
+            <a:r>
+              <a:t>Company chat calls POST /api/ai/company/chat.</a:t>
+            </a:r>
+          </a:p>
+          <a:p>
+            <a:pPr>
+              <a:defRPr sz="1700">
+                <a:solidFill>
+                  <a:srgbClr val="0F172A"/>
+                </a:solidFill>
+              </a:defRPr>
+            </a:pPr>
+            <a:r>
+              <a:t>Safe .env.example documents local backend URLs and mock IDs.</a:t>
+            </a:r>
+          </a:p>
+        </p:txBody>
+      </p:sp>
+      <p:sp>
+        <p:nvSpPr>
+          <p:cNvPr id="4" name="TextBox 3"/>
+          <p:cNvSpPr txBox="1"/>
+          <p:nvPr/>
+        </p:nvSpPr>
+        <p:spPr>
+          <a:xfrm>
+            <a:off x="6400800" y="1234440"/>
+            <a:ext cx="5303520" cy="3840480"/>
+          </a:xfrm>
+          <a:prstGeom prst="rect">
+            <a:avLst/>
+          </a:prstGeom>
+          <a:noFill/>
+        </p:spPr>
+        <p:txBody>
+          <a:bodyPr wrap="square">
+            <a:spAutoFit/>
+          </a:bodyPr>
+          <a:lstStyle/>
+          <a:p>
+            <a:pPr>
+              <a:defRPr sz="1800" b="1">
+                <a:solidFill>
+                  <a:srgbClr val="1E293B"/>
+                </a:solidFill>
+              </a:defRPr>
+            </a:pPr>
+            <a:r>
+              <a:t>Test status</a:t>
+            </a:r>
+          </a:p>
+          <a:p>
+            <a:pPr>
+              <a:defRPr sz="1400" b="0">
+                <a:solidFill>
+                  <a:srgbClr val="1E293B"/>
+                </a:solidFill>
+              </a:defRPr>
+            </a:pPr>
+            <a:r>
+              <a:t>Applicant AI chat: OK</a:t>
+            </a:r>
+          </a:p>
+          <a:p>
+            <a:pPr>
+              <a:defRPr sz="1400" b="0">
+                <a:solidFill>
+                  <a:srgbClr val="1E293B"/>
+                </a:solidFill>
+              </a:defRPr>
+            </a:pPr>
+            <a:r>
+              <a:t>Company AI chat: OK</a:t>
+            </a:r>
+          </a:p>
+          <a:p>
+            <a:pPr>
+              <a:defRPr sz="1400" b="0">
+                <a:solidFill>
+                  <a:srgbClr val="1E293B"/>
+                </a:solidFill>
+              </a:defRPr>
+            </a:pPr>
+            <a:r>
+              <a:t>AI backend: http://127.0.0.1:8000</a:t>
+            </a:r>
+          </a:p>
+          <a:p>
+            <a:pPr>
+              <a:defRPr sz="1400" b="0">
+                <a:solidFill>
+                  <a:srgbClr val="1E293B"/>
+                </a:solidFill>
+              </a:defRPr>
+            </a:pPr>
+            <a:r>
+              <a:t>Frontend: http://127.0.0.1:3000</a:t>
+            </a:r>
+          </a:p>
+          <a:p>
+            <a:pPr>
+              <a:defRPr sz="1400" b="0">
+                <a:solidFill>
+                  <a:srgbClr val="1E293B"/>
+                </a:solidFill>
+              </a:defRPr>
+            </a:pPr>
+          </a:p>
+          <a:p>
+            <a:pPr>
+              <a:defRPr sz="1800" b="1">
+                <a:solidFill>
+                  <a:srgbClr val="1E293B"/>
+                </a:solidFill>
+              </a:defRPr>
+            </a:pPr>
+            <a:r>
+              <a:t>Company test record</a:t>
+            </a:r>
+          </a:p>
+          <a:p>
+            <a:pPr>
+              <a:defRPr sz="1400" b="0">
+                <a:solidFill>
+                  <a:srgbClr val="1E293B"/>
+                </a:solidFill>
+              </a:defRPr>
+            </a:pPr>
+            <a:r>
+              <a:t>Lockman and Sons</a:t>
+            </a:r>
+          </a:p>
+          <a:p>
+            <a:pPr>
+              <a:defRPr sz="1400" b="0">
+                <a:solidFill>
+                  <a:srgbClr val="1E293B"/>
+                </a:solidFill>
+              </a:defRPr>
+            </a:pPr>
+            <a:r>
+              <a:t>CompanyID: AB16E3E4-B398-454E-B62B-0F2D6BAD9411</a:t>
+            </a:r>
+          </a:p>
+          <a:p>
+            <a:pPr>
+              <a:defRPr sz="1400" b="0">
+                <a:solidFill>
+                  <a:srgbClr val="1E293B"/>
+                </a:solidFill>
+              </a:defRPr>
+            </a:pPr>
+            <a:r>
+              <a:t>Email: Liza30@hotmail.com</a:t>
+            </a:r>
+          </a:p>
+        </p:txBody>
+      </p:sp>
+    </p:spTree>
+  </p:cSld>
+  <p:clrMapOvr>
+    <a:masterClrMapping/>
+  </p:clrMapOvr>
+</p:sld>
+</file>
+
 <file path=ppt/slides/slide3.xml><?xml version="1.0" encoding="utf-8"?>
 <p:sld xmlns:a="http://schemas.openxmlformats.org/drawingml/2006/main" xmlns:p="http://schemas.openxmlformats.org/presentationml/2006/main" xmlns:r="http://schemas.openxmlformats.org/officeDocument/2006/relationships">
   <p:cSld>

</xml_diff>